<commit_message>
dashboard updated with event booking icon
</commit_message>
<xml_diff>
--- a/docs/Sarovar-Restaurant-Website-Proposal.pptx
+++ b/docs/Sarovar-Restaurant-Website-Proposal.pptx
@@ -15433,7 +15433,7 @@
               <a:buNone/>
             </a:pPr>
             <a:r>
-              <a:rPr lang="en-US" sz="3800" b="1" dirty="0">
+              <a:rPr lang="en-US" sz="3800" b="1">
                 <a:solidFill>
                   <a:srgbClr val="FFFFFF"/>
                 </a:solidFill>
@@ -15441,7 +15441,7 @@
                 <a:ea typeface="Georgia" pitchFamily="34" charset="-122"/>
                 <a:cs typeface="Georgia" pitchFamily="34" charset="-120"/>
               </a:rPr>
-              <a:t>₹35,000</a:t>
+              <a:t>₹40,000</a:t>
             </a:r>
             <a:endParaRPr lang="en-US" sz="3800" dirty="0"/>
           </a:p>

</xml_diff>